<commit_message>
Product Variant item- Working with delete and status feature
</commit_message>
<xml_diff>
--- a/.lessons/58 Backend Product And Related Features/29 Product Variant item- Working with delete and status feature/1.pptx
+++ b/.lessons/58 Backend Product And Related Features/29 Product Variant item- Working with delete and status feature/1.pptx
@@ -261,7 +261,7 @@
           <a:p>
             <a:fld id="{3E102D2E-813C-461C-9963-687A650C48C0}" type="datetimeFigureOut">
               <a:rPr lang="en-US" smtClean="0"/>
-              <a:t>6/26/2025</a:t>
+              <a:t>10/9/2025</a:t>
             </a:fld>
             <a:endParaRPr lang="en-US"/>
           </a:p>
@@ -459,7 +459,7 @@
           <a:p>
             <a:fld id="{3E102D2E-813C-461C-9963-687A650C48C0}" type="datetimeFigureOut">
               <a:rPr lang="en-US" smtClean="0"/>
-              <a:t>6/26/2025</a:t>
+              <a:t>10/9/2025</a:t>
             </a:fld>
             <a:endParaRPr lang="en-US"/>
           </a:p>
@@ -667,7 +667,7 @@
           <a:p>
             <a:fld id="{3E102D2E-813C-461C-9963-687A650C48C0}" type="datetimeFigureOut">
               <a:rPr lang="en-US" smtClean="0"/>
-              <a:t>6/26/2025</a:t>
+              <a:t>10/9/2025</a:t>
             </a:fld>
             <a:endParaRPr lang="en-US"/>
           </a:p>
@@ -865,7 +865,7 @@
           <a:p>
             <a:fld id="{3E102D2E-813C-461C-9963-687A650C48C0}" type="datetimeFigureOut">
               <a:rPr lang="en-US" smtClean="0"/>
-              <a:t>6/26/2025</a:t>
+              <a:t>10/9/2025</a:t>
             </a:fld>
             <a:endParaRPr lang="en-US"/>
           </a:p>
@@ -1140,7 +1140,7 @@
           <a:p>
             <a:fld id="{3E102D2E-813C-461C-9963-687A650C48C0}" type="datetimeFigureOut">
               <a:rPr lang="en-US" smtClean="0"/>
-              <a:t>6/26/2025</a:t>
+              <a:t>10/9/2025</a:t>
             </a:fld>
             <a:endParaRPr lang="en-US"/>
           </a:p>
@@ -1405,7 +1405,7 @@
           <a:p>
             <a:fld id="{3E102D2E-813C-461C-9963-687A650C48C0}" type="datetimeFigureOut">
               <a:rPr lang="en-US" smtClean="0"/>
-              <a:t>6/26/2025</a:t>
+              <a:t>10/9/2025</a:t>
             </a:fld>
             <a:endParaRPr lang="en-US"/>
           </a:p>
@@ -1817,7 +1817,7 @@
           <a:p>
             <a:fld id="{3E102D2E-813C-461C-9963-687A650C48C0}" type="datetimeFigureOut">
               <a:rPr lang="en-US" smtClean="0"/>
-              <a:t>6/26/2025</a:t>
+              <a:t>10/9/2025</a:t>
             </a:fld>
             <a:endParaRPr lang="en-US"/>
           </a:p>
@@ -1958,7 +1958,7 @@
           <a:p>
             <a:fld id="{3E102D2E-813C-461C-9963-687A650C48C0}" type="datetimeFigureOut">
               <a:rPr lang="en-US" smtClean="0"/>
-              <a:t>6/26/2025</a:t>
+              <a:t>10/9/2025</a:t>
             </a:fld>
             <a:endParaRPr lang="en-US"/>
           </a:p>
@@ -2071,7 +2071,7 @@
           <a:p>
             <a:fld id="{3E102D2E-813C-461C-9963-687A650C48C0}" type="datetimeFigureOut">
               <a:rPr lang="en-US" smtClean="0"/>
-              <a:t>6/26/2025</a:t>
+              <a:t>10/9/2025</a:t>
             </a:fld>
             <a:endParaRPr lang="en-US"/>
           </a:p>
@@ -2382,7 +2382,7 @@
           <a:p>
             <a:fld id="{3E102D2E-813C-461C-9963-687A650C48C0}" type="datetimeFigureOut">
               <a:rPr lang="en-US" smtClean="0"/>
-              <a:t>6/26/2025</a:t>
+              <a:t>10/9/2025</a:t>
             </a:fld>
             <a:endParaRPr lang="en-US"/>
           </a:p>
@@ -2670,7 +2670,7 @@
           <a:p>
             <a:fld id="{3E102D2E-813C-461C-9963-687A650C48C0}" type="datetimeFigureOut">
               <a:rPr lang="en-US" smtClean="0"/>
-              <a:t>6/26/2025</a:t>
+              <a:t>10/9/2025</a:t>
             </a:fld>
             <a:endParaRPr lang="en-US"/>
           </a:p>
@@ -2911,7 +2911,7 @@
           <a:p>
             <a:fld id="{3E102D2E-813C-461C-9963-687A650C48C0}" type="datetimeFigureOut">
               <a:rPr lang="en-US" smtClean="0"/>
-              <a:t>6/26/2025</a:t>
+              <a:t>10/9/2025</a:t>
             </a:fld>
             <a:endParaRPr lang="en-US"/>
           </a:p>
@@ -3369,21 +3369,54 @@
               <a:buNone/>
             </a:pPr>
             <a:r>
-              <a:rPr kumimoji="0" lang="en-US" altLang="en-US" sz="1300" b="0" i="0" u="none" strike="noStrike" cap="none" normalizeH="0" baseline="0">
-                <a:ln>
-                  <a:noFill/>
-                </a:ln>
-                <a:solidFill>
-                  <a:schemeClr val="tx1"/>
-                </a:solidFill>
-                <a:effectLst/>
+              <a:rPr lang="en-US" altLang="en-US" sz="1300">
                 <a:latin typeface="Arial" panose="020B0604020202020204" pitchFamily="34" charset="0"/>
               </a:rPr>
-              <a:t>.</a:t>
-            </a:r>
-          </a:p>
-        </p:txBody>
-      </p:sp>
+              <a:t>app\Http\Controllers\Backend\ProductVariantItemController.php</a:t>
+            </a:r>
+            <a:endParaRPr kumimoji="0" lang="en-US" altLang="en-US" sz="1300" b="0" i="0" u="none" strike="noStrike" cap="none" normalizeH="0" baseline="0">
+              <a:ln>
+                <a:noFill/>
+              </a:ln>
+              <a:solidFill>
+                <a:schemeClr val="tx1"/>
+              </a:solidFill>
+              <a:effectLst/>
+              <a:latin typeface="Arial" panose="020B0604020202020204" pitchFamily="34" charset="0"/>
+            </a:endParaRPr>
+          </a:p>
+        </p:txBody>
+      </p:sp>
+      <p:pic>
+        <p:nvPicPr>
+          <p:cNvPr id="4" name="Picture 3">
+            <a:extLst>
+              <a:ext uri="{FF2B5EF4-FFF2-40B4-BE49-F238E27FC236}">
+                <a16:creationId xmlns:a16="http://schemas.microsoft.com/office/drawing/2014/main" id="{1943BB16-DAA2-89C7-8953-633DE77DD346}"/>
+              </a:ext>
+            </a:extLst>
+          </p:cNvPr>
+          <p:cNvPicPr>
+            <a:picLocks noChangeAspect="1"/>
+          </p:cNvPicPr>
+          <p:nvPr/>
+        </p:nvPicPr>
+        <p:blipFill>
+          <a:blip r:embed="rId2"/>
+          <a:stretch>
+            <a:fillRect/>
+          </a:stretch>
+        </p:blipFill>
+        <p:spPr>
+          <a:xfrm>
+            <a:off x="6212846" y="0"/>
+            <a:ext cx="5979154" cy="6858000"/>
+          </a:xfrm>
+          <a:prstGeom prst="rect">
+            <a:avLst/>
+          </a:prstGeom>
+        </p:spPr>
+      </p:pic>
     </p:spTree>
     <p:extLst>
       <p:ext uri="{BB962C8B-B14F-4D97-AF65-F5344CB8AC3E}">

</xml_diff>